<commit_message>
Clarify entropy feature is traffic variability proxy, not Shannon entropy
Updated documentation across all source files (real_data.py, components.py,
data.py, experiments.py, enhanced_evaluation.py) to clarify that the
'entropy' column is a traffic variability proxy derived from:
- UNSW-NB15: ct_srv_src (connection diversity), min-max normalized
- CIC datasets: Fwd IAT Std (timing variability), quantile-normalized
Column name kept for backward compatibility; comments explain derivation.
Slides updated with asterisk notation and footnote on dataset slide.

Co-Authored-By: Claude Opus 4.6 <noreply@anthropic.com>
</commit_message>
<xml_diff>
--- a/ASRRL_Methodology.pptx
+++ b/ASRRL_Methodology.pptx
@@ -5625,7 +5625,7 @@
                 </a:solidFill>
                 <a:latin typeface="Times New Roman"/>
               </a:rPr>
-              <a:t>σ_ent ← std({entropy(x) : x ∈ B_t})  // entropy volatility</a:t>
+              <a:t>σ_var ← std({variability(x) : x ∈ B_t})  // traffic variability volatility</a:t>
             </a:r>
           </a:p>
           <a:p>
@@ -6123,7 +6123,7 @@
               </a:defRPr>
             </a:pPr>
             <a:r>
-              <a:t>•  Dynamically resizes the flow buffer (10–200 flows) based on traffic volatility measured by entropy std and byte rate variance.</a:t>
+              <a:t>•  Dynamically resizes the flow buffer (10–200 flows) based on traffic volatility measured by variability proxy std and byte rate variance.</a:t>
             </a:r>
           </a:p>
           <a:p>
@@ -10493,7 +10493,7 @@
               </a:defRPr>
             </a:pPr>
             <a:r>
-              <a:t>Stage 1:  Raw columns (dur, rate, sbytes, ...)  →  x_i = [flow_duration, pkt_rate, byte_rate, entropy, port_cat, size_cat, protocol] ∈ R^7</a:t>
+              <a:t>Stage 1:  Raw columns (dur, rate, sbytes, ...)  →  x_i = [flow_duration, pkt_rate, byte_rate, entropy*, port_cat, size_cat, protocol] ∈ R^7</a:t>
             </a:r>
           </a:p>
           <a:p>
@@ -10573,7 +10573,7 @@
               </a:defRPr>
             </a:pPr>
             <a:r>
-              <a:t>Stage 6:  σ_entropy, σ²_bytes of window W_t → |B_{t+1}| = clip(|B_t| ± Δ, 10, 200)</a:t>
+              <a:t>Stage 6:  σ_variability, σ²_bytes of window W_t → |B_{t+1}| = clip(|B_t| ± Δ, 10, 200)</a:t>
             </a:r>
           </a:p>
           <a:p>
@@ -10929,7 +10929,7 @@
               </a:defRPr>
             </a:pPr>
             <a:r>
-              <a:t>  entropy       = normalize(ct_srv_src, [0,1])</a:t>
+              <a:t>  entropy*      = normalize(ct_srv_src, [0,1])</a:t>
             </a:r>
           </a:p>
           <a:p>
@@ -11316,7 +11316,7 @@
               </a:defRPr>
             </a:pPr>
             <a:r>
-              <a:t>  entropy       = quantile_norm(Fwd IAT Std)</a:t>
+              <a:t>  entropy*      = quantile_norm(Fwd IAT Std)</a:t>
             </a:r>
           </a:p>
           <a:p>
@@ -11703,7 +11703,7 @@
               </a:defRPr>
             </a:pPr>
             <a:r>
-              <a:t>  entropy       = quantile_norm(Fwd IAT Std)</a:t>
+              <a:t>  entropy*      = quantile_norm(Fwd IAT Std)</a:t>
             </a:r>
           </a:p>
           <a:p>
@@ -11836,6 +11836,42 @@
       <p:sp>
         <p:nvSpPr>
           <p:cNvPr id="9" name="TextBox 8"/>
+          <p:cNvSpPr txBox="1"/>
+          <p:nvPr/>
+        </p:nvSpPr>
+        <p:spPr>
+          <a:xfrm>
+            <a:off x="274320" y="5852160"/>
+            <a:ext cx="11430000" cy="274320"/>
+          </a:xfrm>
+          <a:prstGeom prst="rect">
+            <a:avLst/>
+          </a:prstGeom>
+          <a:noFill/>
+        </p:spPr>
+        <p:txBody>
+          <a:bodyPr wrap="square">
+            <a:spAutoFit/>
+          </a:bodyPr>
+          <a:lstStyle/>
+          <a:p>
+            <a:pPr algn="l">
+              <a:defRPr sz="1000" b="0">
+                <a:solidFill>
+                  <a:srgbClr val="7F8C8D"/>
+                </a:solidFill>
+                <a:latin typeface="Calibri"/>
+              </a:defRPr>
+            </a:pPr>
+            <a:r>
+              <a:t>*entropy is a traffic variability proxy (NOT Shannon entropy): UNSW uses ct_srv_src (connection diversity); CIC datasets use Fwd IAT Std (timing variability), both normalized to [0,1].</a:t>
+            </a:r>
+          </a:p>
+        </p:txBody>
+      </p:sp>
+      <p:sp>
+        <p:nvSpPr>
+          <p:cNvPr id="10" name="TextBox 9"/>
           <p:cNvSpPr txBox="1"/>
           <p:nvPr/>
         </p:nvSpPr>
@@ -11864,7 +11900,7 @@
               </a:defRPr>
             </a:pPr>
             <a:r>
-              <a:t>All 3 datasets → Standardized schema:  x_i = [flow_duration, pkt_rate, byte_rate, entropy, port_cat, size_cat, protocol],  y_i ∈ {0,1}</a:t>
+              <a:t>All 3 datasets → Standardized schema:  x_i = [flow_duration, pkt_rate, byte_rate, entropy*, port_cat, size_cat, protocol],  y_i ∈ {0,1}</a:t>
             </a:r>
           </a:p>
         </p:txBody>
@@ -13869,7 +13905,7 @@
               </a:defRPr>
             </a:pPr>
             <a:r>
-              <a:t>•  Maps the 49–80+ raw CSV columns from Stage 0 into a unified 7-dimensional representation: [flow_duration, pkt_rate, byte_rate, entropy, port_cat, size_cat, protocol].</a:t>
+              <a:t>•  Maps the 49–80+ raw CSV columns from Stage 0 into a unified 7-dimensional representation: [flow_duration, pkt_rate, byte_rate, entropy*, port_cat, size_cat, protocol]. *entropy is a traffic variability proxy, not Shannon entropy.</a:t>
             </a:r>
           </a:p>
           <a:p>

</xml_diff>

<commit_message>
Rename entropy column to traffic_pat_var across entire codebase
Renamed the 'entropy' feature to 'traffic_pat_var' (traffic pattern
variability) in all 8 source files to accurately reflect that it is
NOT Shannon information entropy but a traffic variability proxy:
- UNSW-NB15: min-max normalized ct_srv_src (connection diversity)
- CIC datasets: quantile-normalized Fwd IAT Std (timing variability)

Updated: real_data.py, components.py, data.py, experiments.py,
enhanced_evaluation.py, pipeline.py, rl_agents.py, create_pptx.py.

Added ingested data CSVs: table_ingested_data.csv (150 sample flows),
table_feature_mapping.csv (raw-to-standardized mappings per dataset),
table_pcap_sources.csv (PCAP source reference).

Co-Authored-By: Claude Opus 4.6 <noreply@anthropic.com>
</commit_message>
<xml_diff>
--- a/ASRRL_Methodology.pptx
+++ b/ASRRL_Methodology.pptx
@@ -5625,7 +5625,7 @@
                 </a:solidFill>
                 <a:latin typeface="Times New Roman"/>
               </a:rPr>
-              <a:t>σ_var ← std({variability(x) : x ∈ B_t})  // traffic variability volatility</a:t>
+              <a:t>σ_tpv ← std({traffic_pat_var(x) : x ∈ B_t})  // traffic pattern variability volatility</a:t>
             </a:r>
           </a:p>
           <a:p>
@@ -5681,7 +5681,7 @@
                 </a:solidFill>
                 <a:latin typeface="Times New Roman"/>
               </a:rPr>
-              <a:t>volatility ← σ_ent + σ²_bytes / max(σ²_bytes)</a:t>
+              <a:t>volatility ← σ_tpv + σ²_bytes / max(σ²_bytes)</a:t>
             </a:r>
           </a:p>
           <a:p>
@@ -6123,7 +6123,7 @@
               </a:defRPr>
             </a:pPr>
             <a:r>
-              <a:t>•  Dynamically resizes the flow buffer (10–200 flows) based on traffic volatility measured by variability proxy std and byte rate variance.</a:t>
+              <a:t>•  Dynamically resizes the flow buffer (10–200 flows) based on traffic volatility measured by traffic_pat_var std and byte rate variance.</a:t>
             </a:r>
           </a:p>
           <a:p>
@@ -10493,7 +10493,7 @@
               </a:defRPr>
             </a:pPr>
             <a:r>
-              <a:t>Stage 1:  Raw columns (dur, rate, sbytes, ...)  →  x_i = [flow_duration, pkt_rate, byte_rate, entropy*, port_cat, size_cat, protocol] ∈ R^7</a:t>
+              <a:t>Stage 1:  Raw columns (dur, rate, sbytes, ...)  →  x_i = [flow_duration, pkt_rate, byte_rate, traffic_pat_var*, port_cat, size_cat, protocol] ∈ R^7</a:t>
             </a:r>
           </a:p>
           <a:p>
@@ -10573,7 +10573,7 @@
               </a:defRPr>
             </a:pPr>
             <a:r>
-              <a:t>Stage 6:  σ_variability, σ²_bytes of window W_t → |B_{t+1}| = clip(|B_t| ± Δ, 10, 200)</a:t>
+              <a:t>Stage 6:  σ_tpv, σ²_bytes of window W_t → |B_{t+1}| = clip(|B_t| ± Δ, 10, 200)</a:t>
             </a:r>
           </a:p>
           <a:p>
@@ -10929,7 +10929,7 @@
               </a:defRPr>
             </a:pPr>
             <a:r>
-              <a:t>  entropy*      = normalize(ct_srv_src, [0,1])</a:t>
+              <a:t>  traffic_pat_var* = normalize(ct_srv_src, [0,1])</a:t>
             </a:r>
           </a:p>
           <a:p>
@@ -11316,7 +11316,7 @@
               </a:defRPr>
             </a:pPr>
             <a:r>
-              <a:t>  entropy*      = quantile_norm(Fwd IAT Std)</a:t>
+              <a:t>  traffic_pat_var* = quantile_norm(Fwd IAT Std)</a:t>
             </a:r>
           </a:p>
           <a:p>
@@ -11703,7 +11703,7 @@
               </a:defRPr>
             </a:pPr>
             <a:r>
-              <a:t>  entropy*      = quantile_norm(Fwd IAT Std)</a:t>
+              <a:t>  traffic_pat_var* = quantile_norm(Fwd IAT Std)</a:t>
             </a:r>
           </a:p>
           <a:p>
@@ -11864,7 +11864,7 @@
               </a:defRPr>
             </a:pPr>
             <a:r>
-              <a:t>*entropy is a traffic variability proxy (NOT Shannon entropy): UNSW uses ct_srv_src (connection diversity); CIC datasets use Fwd IAT Std (timing variability), both normalized to [0,1].</a:t>
+              <a:t>*traffic_pat_var is a traffic pattern variability proxy (NOT Shannon entropy): UNSW uses ct_srv_src (connection diversity); CIC datasets use Fwd IAT Std (timing variability), both normalized to [0,1].</a:t>
             </a:r>
           </a:p>
         </p:txBody>
@@ -11900,7 +11900,7 @@
               </a:defRPr>
             </a:pPr>
             <a:r>
-              <a:t>All 3 datasets → Standardized schema:  x_i = [flow_duration, pkt_rate, byte_rate, entropy*, port_cat, size_cat, protocol],  y_i ∈ {0,1}</a:t>
+              <a:t>All 3 datasets → Standardized schema:  x_i = [flow_duration, pkt_rate, byte_rate, traffic_pat_var*, port_cat, size_cat, protocol],  y_i ∈ {0,1}</a:t>
             </a:r>
           </a:p>
         </p:txBody>
@@ -13905,7 +13905,7 @@
               </a:defRPr>
             </a:pPr>
             <a:r>
-              <a:t>•  Maps the 49–80+ raw CSV columns from Stage 0 into a unified 7-dimensional representation: [flow_duration, pkt_rate, byte_rate, entropy*, port_cat, size_cat, protocol]. *entropy is a traffic variability proxy, not Shannon entropy.</a:t>
+              <a:t>•  Maps the 49–80+ raw CSV columns from Stage 0 into a unified 7-dimensional representation: [flow_duration, pkt_rate, byte_rate, traffic_pat_var*, port_cat, size_cat, protocol]. *traffic_pat_var is a traffic pattern variability proxy, not Shannon entropy.</a:t>
             </a:r>
           </a:p>
           <a:p>

</xml_diff>